<commit_message>
feat: add QR code linking to the repo on the title slide
</commit_message>
<xml_diff>
--- a/Crossplane_Enterprise_IaC.pptx
+++ b/Crossplane_Enterprise_IaC.pptx
@@ -2750,6 +2750,96 @@
           </a:p>
         </p:txBody>
       </p:sp>
+      <p:sp>
+        <p:nvSpPr>
+          <p:cNvPr id="19" name="Shape 12"/>
+          <p:cNvSpPr/>
+          <p:nvPr/>
+        </p:nvSpPr>
+        <p:spPr>
+          <a:xfrm>
+            <a:off x="9235440" y="4892040"/>
+            <a:ext cx="1737360" cy="1417320"/>
+          </a:xfrm>
+          <a:prstGeom prst="roundRect">
+            <a:avLst>
+              <a:gd name="adj" fmla="val 5161"/>
+            </a:avLst>
+          </a:prstGeom>
+          <a:solidFill>
+            <a:srgbClr val="FFFFFF"/>
+          </a:solidFill>
+          <a:ln w="12700">
+            <a:solidFill>
+              <a:srgbClr val="5FD0C0"/>
+            </a:solidFill>
+            <a:prstDash val="solid"/>
+          </a:ln>
+        </p:spPr>
+      </p:sp>
+      <p:sp>
+        <p:nvSpPr>
+          <p:cNvPr id="20" name="Text 13"/>
+          <p:cNvSpPr/>
+          <p:nvPr/>
+        </p:nvSpPr>
+        <p:spPr>
+          <a:xfrm>
+            <a:off x="9235440" y="4965192"/>
+            <a:ext cx="1737360" cy="219456"/>
+          </a:xfrm>
+          <a:prstGeom prst="rect">
+            <a:avLst/>
+          </a:prstGeom>
+          <a:noFill/>
+          <a:ln/>
+        </p:spPr>
+        <p:txBody>
+          <a:bodyPr wrap="square" lIns="0" tIns="0" rIns="0" bIns="0" rtlCol="0" anchor="ctr"/>
+          <a:lstStyle/>
+          <a:p>
+            <a:pPr algn="ctr" indent="0" marL="0">
+              <a:buNone/>
+            </a:pPr>
+            <a:r>
+              <a:rPr lang="en-US" sz="850" b="1" dirty="0">
+                <a:solidFill>
+                  <a:srgbClr val="0B1E3D"/>
+                </a:solidFill>
+                <a:latin typeface="Calibri" pitchFamily="34" charset="0"/>
+                <a:ea typeface="Calibri" pitchFamily="34" charset="-122"/>
+                <a:cs typeface="Calibri" pitchFamily="34" charset="-120"/>
+              </a:rPr>
+              <a:t>Scan for the repo</a:t>
+            </a:r>
+            <a:endParaRPr lang="en-US" sz="850" dirty="0"/>
+          </a:p>
+        </p:txBody>
+      </p:sp>
+      <p:pic>
+        <p:nvPicPr>
+          <p:cNvPr id="21" name="Image 5" descr="icons/qrcode.png">    </p:cNvPr>
+          <p:cNvPicPr>
+            <a:picLocks noChangeAspect="1"/>
+          </p:cNvPicPr>
+          <p:nvPr/>
+        </p:nvPicPr>
+        <p:blipFill>
+          <a:blip r:embed="rId6"/>
+          <a:stretch>
+            <a:fillRect/>
+          </a:stretch>
+        </p:blipFill>
+        <p:spPr>
+          <a:xfrm>
+            <a:off x="9601200" y="5212080"/>
+            <a:ext cx="1005840" cy="1005840"/>
+          </a:xfrm>
+          <a:prstGeom prst="rect">
+            <a:avLst/>
+          </a:prstGeom>
+        </p:spPr>
+      </p:pic>
     </p:spTree>
   </p:cSld>
   <p:clrMapOvr>

</xml_diff>